<commit_message>
Defense deck: S8 cost honesty + S9 de-clutter + new A5 + S10/S11 numbers
Batch B (Tasks 5-7 from plan). S8 'cost table' is a grid of free-floating
text shapes, not a real table — repurposed the last grid row (Perception
PC / -) into a 'Total / approx USD 358' row. New A5 hidden appendix slide
carries the firmware excerpt that left S9. Idempotent — script verified
twice produces identical 23-slide output.

Co-Authored-By: Claude Opus 4.7 <noreply@anthropic.com>
</commit_message>
<xml_diff>
--- a/thesis_defense_presentation/thesis_defense_final_revised.pptx
+++ b/thesis_defense_presentation/thesis_defense_final_revised.pptx
@@ -30,6 +30,7 @@
     <p:sldId id="314" r:id="rId21"/>
     <p:sldId id="315" r:id="rId22"/>
     <p:sldId id="316" r:id="rId23"/>
+    <p:sldId id="317" r:id="rId29"/>
   </p:sldIdLst>
   <p:sldSz cx="12192000" cy="6858000"/>
   <p:notesSz cx="6858000" cy="9144000"/>
@@ -18759,7 +18760,26 @@
           <a:lstStyle/>
           <a:p>
             <a:r>
-              <a:t>Unifying four cameras into one millimetre-scale world frame.</a:t>
+              <a:rPr/>
+              <a:t>Intrinsic: ChArUco board, reproj 2-8 px (Sec 5.1)</a:t>
+            </a:r>
+          </a:p>
+          <a:p>
+            <a:r>
+              <a:rPr/>
+              <a:t>Extrinsic: 24 AprilTags + RANSAC + σ=2.0 sigma-clipping (Sec 3.5.2)</a:t>
+            </a:r>
+          </a:p>
+          <a:p>
+            <a:r>
+              <a:rPr/>
+              <a:t>Extrinsic RMSE: 3-7 px after 8-15 % outlier rejection (Sec 5.2)</a:t>
+            </a:r>
+          </a:p>
+          <a:p>
+            <a:r>
+              <a:rPr/>
+              <a:t>Overlay validation: reprojected corners within 5-10 px on all 4 cams</a:t>
             </a:r>
           </a:p>
         </p:txBody>
@@ -20316,11 +20336,10 @@
           <a:lstStyle/>
           <a:p>
             <a:r>
-              <a:rPr lang="en-US" sz="1600" dirty="0">
-                <a:latin typeface="Arial" panose="020B0604020202020204" pitchFamily="34" charset="0"/>
-                <a:cs typeface="Arial" panose="020B0604020202020204" pitchFamily="34" charset="0"/>
+              <a:rPr sz="1600">
+                <a:latin typeface="Arial"/>
               </a:rPr>
-              <a:t>3D trajectory verified</a:t>
+              <a:t>&lt;800 mm frame-to-frame jumps (slow), motion-blur stress (fast), near-zero false-positive (no-ball)</a:t>
             </a:r>
             <a:endParaRPr sz="1600" dirty="0">
               <a:latin typeface="Arial" panose="020B0604020202020204" pitchFamily="34" charset="0"/>
@@ -20589,10 +20608,9 @@
           <a:p>
             <a:r>
               <a:rPr sz="1600">
-                <a:latin typeface="Arial" panose="020B0604020202020204" pitchFamily="34" charset="0"/>
-                <a:cs typeface="Arial" panose="020B0604020202020204" pitchFamily="34" charset="0"/>
+                <a:latin typeface="Arial"/>
               </a:rPr>
-              <a:t>Ball mean drops to 95.17 mm</a:t>
+              <a:t>Raw 150.77 mm → corrected 95.17 mm (Fig 5.1)</a:t>
             </a:r>
           </a:p>
         </p:txBody>
@@ -21217,34 +21235,13 @@
               <a:buNone/>
             </a:pPr>
             <a:r>
-              <a:rPr lang="en-US" sz="1600" b="0" i="1" dirty="0">
+              <a:rPr sz="1600" b="0" i="1">
                 <a:solidFill>
                   <a:srgbClr val="FFFFFF"/>
                 </a:solidFill>
-                <a:latin typeface="Arial" panose="020B0604020202020204" pitchFamily="34" charset="0"/>
-                <a:cs typeface="Arial" panose="020B0604020202020204" pitchFamily="34" charset="0"/>
+                <a:latin typeface="Arial"/>
               </a:rPr>
-              <a:t>Takeaway: quantitative </a:t>
-            </a:r>
-            <a:r>
-              <a:rPr lang="en-US" sz="1600" b="0" i="1" dirty="0" err="1">
-                <a:solidFill>
-                  <a:srgbClr val="FFFFFF"/>
-                </a:solidFill>
-                <a:latin typeface="Arial" panose="020B0604020202020204" pitchFamily="34" charset="0"/>
-                <a:cs typeface="Arial" panose="020B0604020202020204" pitchFamily="34" charset="0"/>
-              </a:rPr>
-              <a:t>localisation</a:t>
-            </a:r>
-            <a:r>
-              <a:rPr lang="en-US" sz="1600" b="0" i="1" dirty="0">
-                <a:solidFill>
-                  <a:srgbClr val="FFFFFF"/>
-                </a:solidFill>
-                <a:latin typeface="Arial" panose="020B0604020202020204" pitchFamily="34" charset="0"/>
-                <a:cs typeface="Arial" panose="020B0604020202020204" pitchFamily="34" charset="0"/>
-              </a:rPr>
-              <a:t>, safety gates, and logging support controlled live-aim validation.</a:t>
+              <a:t>Takeaway: localisation, dynamic stability, and safety logging satisfy static + live-aim acceptance. Bias correction was fitted in-sample on the same 36-pt set (Sec 4.4.2, 6.3).</a:t>
             </a:r>
           </a:p>
         </p:txBody>
@@ -31686,6 +31683,1796 @@
 </p:sld>
 </file>
 
+<file path=ppt/slides/slide23.xml><?xml version="1.0" encoding="utf-8"?>
+<p:sld xmlns:a="http://schemas.openxmlformats.org/drawingml/2006/main" xmlns:p="http://schemas.openxmlformats.org/presentationml/2006/main" xmlns:r="http://schemas.openxmlformats.org/officeDocument/2006/relationships" show="0">
+  <p:cSld>
+    <p:spTree>
+      <p:nvGrpSpPr>
+        <p:cNvPr id="1" name=""/>
+        <p:cNvGrpSpPr/>
+        <p:nvPr/>
+      </p:nvGrpSpPr>
+      <p:grpSpPr/>
+      <p:sp>
+        <p:nvSpPr>
+          <p:cNvPr id="141" name="BottomBar"/>
+          <p:cNvSpPr/>
+          <p:nvPr/>
+        </p:nvSpPr>
+        <p:spPr>
+          <a:xfrm>
+            <a:off x="0" y="6537960"/>
+            <a:ext cx="12192000" cy="320040"/>
+          </a:xfrm>
+          <a:prstGeom prst="rect">
+            <a:avLst/>
+          </a:prstGeom>
+          <a:solidFill>
+            <a:srgbClr val="F5F2ED"/>
+          </a:solidFill>
+          <a:ln>
+            <a:noFill/>
+          </a:ln>
+        </p:spPr>
+        <p:style>
+          <a:lnRef idx="1">
+            <a:schemeClr val="accent1"/>
+          </a:lnRef>
+          <a:fillRef idx="3">
+            <a:schemeClr val="accent1"/>
+          </a:fillRef>
+          <a:effectRef idx="2">
+            <a:schemeClr val="accent1"/>
+          </a:effectRef>
+          <a:fontRef idx="minor">
+            <a:schemeClr val="lt1"/>
+          </a:fontRef>
+        </p:style>
+        <p:txBody>
+          <a:bodyPr rtlCol="0" anchor="ctr"/>
+          <a:lstStyle/>
+          <a:p>
+            <a:pPr algn="ctr"/>
+            <a:endParaRPr/>
+          </a:p>
+        </p:txBody>
+      </p:sp>
+      <p:pic>
+        <p:nvPicPr>
+          <p:cNvPr id="140" name="NUThemeBackground" descr="nu_theme-2.png"/>
+          <p:cNvPicPr>
+            <a:picLocks noChangeAspect="1"/>
+          </p:cNvPicPr>
+          <p:nvPr/>
+        </p:nvPicPr>
+        <p:blipFill>
+          <a:blip r:embed="rId3"/>
+          <a:stretch>
+            <a:fillRect/>
+          </a:stretch>
+        </p:blipFill>
+        <p:spPr>
+          <a:xfrm>
+            <a:off x="0" y="0"/>
+            <a:ext cx="12192000" cy="6858000"/>
+          </a:xfrm>
+          <a:prstGeom prst="rect">
+            <a:avLst/>
+          </a:prstGeom>
+        </p:spPr>
+      </p:pic>
+      <p:sp>
+        <p:nvSpPr>
+          <p:cNvPr id="2" name="Title 1">
+            <a:extLst>
+              <a:ext uri="{FF2B5EF4-FFF2-40B4-BE49-F238E27FC236}">
+                <a16:creationId xmlns:a16="http://schemas.microsoft.com/office/drawing/2014/main" id="{CB47B634-81FA-4540-CC47-DAD39BDB980A}"/>
+              </a:ext>
+            </a:extLst>
+          </p:cNvPr>
+          <p:cNvSpPr>
+            <a:spLocks noGrp="1"/>
+          </p:cNvSpPr>
+          <p:nvPr>
+            <p:ph type="title"/>
+          </p:nvPr>
+        </p:nvSpPr>
+        <p:spPr>
+          <a:xfrm>
+            <a:off x="508000" y="861060"/>
+            <a:ext cx="11176000" cy="711200"/>
+          </a:xfrm>
+        </p:spPr>
+        <p:txBody>
+          <a:bodyPr wrap="square" lIns="76200" tIns="38100" rIns="76200" bIns="38100" anchor="ctr"/>
+          <a:lstStyle/>
+          <a:p>
+            <a:pPr algn="l">
+              <a:buNone/>
+            </a:pPr>
+            <a:r>
+              <a:rPr sz="3200" b="1">
+                <a:solidFill>
+                  <a:srgbClr val="1F1F1F"/>
+                </a:solidFill>
+                <a:latin typeface="Calibri"/>
+              </a:rPr>
+              <a:t>A5 · Firmware command excerpt</a:t>
+            </a:r>
+          </a:p>
+        </p:txBody>
+      </p:sp>
+      <p:sp>
+        <p:nvSpPr>
+          <p:cNvPr id="101" name="t101"/>
+          <p:cNvSpPr txBox="1"/>
+          <p:nvPr/>
+        </p:nvSpPr>
+        <p:spPr>
+          <a:xfrm>
+            <a:off x="457200" y="1623430"/>
+            <a:ext cx="11176000" cy="457200"/>
+          </a:xfrm>
+          <a:prstGeom prst="rect">
+            <a:avLst/>
+          </a:prstGeom>
+          <a:noFill/>
+          <a:ln>
+            <a:noFill/>
+          </a:ln>
+        </p:spPr>
+        <p:txBody>
+          <a:bodyPr wrap="square" lIns="76200" tIns="38100" rIns="76200" bIns="38100" anchor="ctr"/>
+          <a:lstStyle/>
+          <a:p>
+            <a:pPr algn="l">
+              <a:buNone/>
+            </a:pPr>
+            <a:r>
+              <a:rPr sz="2200" b="1">
+                <a:solidFill>
+                  <a:srgbClr val="2A231F"/>
+                </a:solidFill>
+                <a:latin typeface="Arial"/>
+              </a:rPr>
+              <a:t>// control_12_full.ino</a:t>
+            </a:r>
+          </a:p>
+          <a:p>
+            <a:r>
+              <a:rPr sz="2200" b="1">
+                <a:solidFill>
+                  <a:srgbClr val="2A231F"/>
+                </a:solidFill>
+                <a:latin typeface="Arial"/>
+              </a:rPr>
+              <a:t>void handle_set(){</a:t>
+            </a:r>
+          </a:p>
+          <a:p>
+            <a:r>
+              <a:rPr sz="2200" b="1">
+                <a:solidFill>
+                  <a:srgbClr val="2A231F"/>
+                </a:solidFill>
+                <a:latin typeface="Arial"/>
+              </a:rPr>
+              <a:t>  // set &lt;v&gt; &lt;h&gt; &lt;wl&gt; &lt;wr&gt;</a:t>
+            </a:r>
+          </a:p>
+          <a:p>
+            <a:r>
+              <a:rPr sz="2200" b="1">
+                <a:solidFill>
+                  <a:srgbClr val="2A231F"/>
+                </a:solidFill>
+                <a:latin typeface="Arial"/>
+              </a:rPr>
+              <a:t>  float v  = Serial.parseFloat();</a:t>
+            </a:r>
+          </a:p>
+          <a:p>
+            <a:r>
+              <a:rPr sz="2200" b="1">
+                <a:solidFill>
+                  <a:srgbClr val="2A231F"/>
+                </a:solidFill>
+                <a:latin typeface="Arial"/>
+              </a:rPr>
+              <a:t>  float h  = Serial.parseFloat();</a:t>
+            </a:r>
+          </a:p>
+          <a:p>
+            <a:r>
+              <a:rPr sz="2200" b="1">
+                <a:solidFill>
+                  <a:srgbClr val="2A231F"/>
+                </a:solidFill>
+                <a:latin typeface="Arial"/>
+              </a:rPr>
+              <a:t>  int   wl = Serial.parseInt();</a:t>
+            </a:r>
+          </a:p>
+          <a:p>
+            <a:r>
+              <a:rPr sz="2200" b="1">
+                <a:solidFill>
+                  <a:srgbClr val="2A231F"/>
+                </a:solidFill>
+                <a:latin typeface="Arial"/>
+              </a:rPr>
+              <a:t>  int   wr = Serial.parseInt();</a:t>
+            </a:r>
+          </a:p>
+          <a:p>
+            <a:r>
+              <a:rPr sz="2200" b="1">
+                <a:solidFill>
+                  <a:srgbClr val="2A231F"/>
+                </a:solidFill>
+                <a:latin typeface="Arial"/>
+              </a:rPr>
+              <a:t>  if(!armed) return;</a:t>
+            </a:r>
+          </a:p>
+          <a:p>
+            <a:r>
+              <a:rPr sz="2200" b="1">
+                <a:solidFill>
+                  <a:srgbClr val="2A231F"/>
+                </a:solidFill>
+                <a:latin typeface="Arial"/>
+              </a:rPr>
+              <a:t>  clampAngle(v, h);</a:t>
+            </a:r>
+          </a:p>
+          <a:p>
+            <a:r>
+              <a:rPr sz="2200" b="1">
+                <a:solidFill>
+                  <a:srgbClr val="2A231F"/>
+                </a:solidFill>
+                <a:latin typeface="Arial"/>
+              </a:rPr>
+              <a:t>  gateRPM(wl, wr);</a:t>
+            </a:r>
+          </a:p>
+          <a:p>
+            <a:r>
+              <a:rPr sz="2200" b="1">
+                <a:solidFill>
+                  <a:srgbClr val="2A231F"/>
+                </a:solidFill>
+                <a:latin typeface="Arial"/>
+              </a:rPr>
+              <a:t>  target_v = v; target_h = h;</a:t>
+            </a:r>
+          </a:p>
+          <a:p>
+            <a:r>
+              <a:rPr sz="2200" b="1">
+                <a:solidFill>
+                  <a:srgbClr val="2A231F"/>
+                </a:solidFill>
+                <a:latin typeface="Arial"/>
+              </a:rPr>
+              <a:t>}</a:t>
+            </a:r>
+          </a:p>
+        </p:txBody>
+      </p:sp>
+      <p:sp>
+        <p:nvSpPr>
+          <p:cNvPr id="102" name="r102"/>
+          <p:cNvSpPr/>
+          <p:nvPr/>
+        </p:nvSpPr>
+        <p:spPr>
+          <a:xfrm>
+            <a:off x="508000" y="2159000"/>
+            <a:ext cx="2540000" cy="457200"/>
+          </a:xfrm>
+          <a:prstGeom prst="rect">
+            <a:avLst/>
+          </a:prstGeom>
+          <a:solidFill>
+            <a:srgbClr val="935739"/>
+          </a:solidFill>
+          <a:ln w="10160">
+            <a:solidFill>
+              <a:srgbClr val="935739"/>
+            </a:solidFill>
+          </a:ln>
+        </p:spPr>
+        <p:txBody>
+          <a:bodyPr wrap="square" lIns="76200" tIns="38100" rIns="76200" bIns="38100" anchor="ctr"/>
+          <a:lstStyle/>
+          <a:p>
+            <a:pPr algn="ctr"/>
+            <a:endParaRPr lang="en-US"/>
+          </a:p>
+        </p:txBody>
+      </p:sp>
+      <p:sp>
+        <p:nvSpPr>
+          <p:cNvPr id="103" name="t103"/>
+          <p:cNvSpPr txBox="1"/>
+          <p:nvPr/>
+        </p:nvSpPr>
+        <p:spPr>
+          <a:xfrm>
+            <a:off x="609600" y="2159000"/>
+            <a:ext cx="2336800" cy="457200"/>
+          </a:xfrm>
+          <a:prstGeom prst="rect">
+            <a:avLst/>
+          </a:prstGeom>
+          <a:noFill/>
+          <a:ln>
+            <a:noFill/>
+          </a:ln>
+        </p:spPr>
+        <p:txBody>
+          <a:bodyPr wrap="square" lIns="76200" tIns="38100" rIns="76200" bIns="38100" anchor="ctr"/>
+          <a:lstStyle/>
+          <a:p>
+            <a:pPr algn="l">
+              <a:buNone/>
+            </a:pPr>
+            <a:r>
+              <a:rPr lang="en-US" sz="1500" b="1" dirty="0">
+                <a:solidFill>
+                  <a:srgbClr val="2A231F"/>
+                </a:solidFill>
+                <a:latin typeface="Arial"/>
+              </a:rPr>
+              <a:t>Course</a:t>
+            </a:r>
+          </a:p>
+        </p:txBody>
+      </p:sp>
+      <p:sp>
+        <p:nvSpPr>
+          <p:cNvPr id="104" name="r104"/>
+          <p:cNvSpPr/>
+          <p:nvPr/>
+        </p:nvSpPr>
+        <p:spPr>
+          <a:xfrm>
+            <a:off x="3048000" y="2159000"/>
+            <a:ext cx="4318000" cy="457200"/>
+          </a:xfrm>
+          <a:prstGeom prst="rect">
+            <a:avLst/>
+          </a:prstGeom>
+          <a:solidFill>
+            <a:srgbClr val="935739"/>
+          </a:solidFill>
+          <a:ln w="10160">
+            <a:solidFill>
+              <a:srgbClr val="935739"/>
+            </a:solidFill>
+          </a:ln>
+        </p:spPr>
+        <p:txBody>
+          <a:bodyPr wrap="square" lIns="76200" tIns="38100" rIns="76200" bIns="38100" anchor="ctr"/>
+          <a:lstStyle/>
+          <a:p>
+            <a:pPr algn="ctr"/>
+            <a:endParaRPr lang="en-US"/>
+          </a:p>
+        </p:txBody>
+      </p:sp>
+      <p:sp>
+        <p:nvSpPr>
+          <p:cNvPr id="105" name="t105"/>
+          <p:cNvSpPr txBox="1"/>
+          <p:nvPr/>
+        </p:nvSpPr>
+        <p:spPr>
+          <a:xfrm>
+            <a:off x="3149600" y="2159000"/>
+            <a:ext cx="4114800" cy="457200"/>
+          </a:xfrm>
+          <a:prstGeom prst="rect">
+            <a:avLst/>
+          </a:prstGeom>
+          <a:noFill/>
+          <a:ln>
+            <a:noFill/>
+          </a:ln>
+        </p:spPr>
+        <p:txBody>
+          <a:bodyPr wrap="square" lIns="76200" tIns="38100" rIns="76200" bIns="38100" anchor="ctr"/>
+          <a:lstStyle/>
+          <a:p>
+            <a:pPr algn="l">
+              <a:buNone/>
+            </a:pPr>
+            <a:r>
+              <a:rPr lang="en-US" sz="1500" b="1" dirty="0">
+                <a:solidFill>
+                  <a:srgbClr val="2A231F"/>
+                </a:solidFill>
+                <a:latin typeface="Arial"/>
+              </a:rPr>
+              <a:t>Concept used</a:t>
+            </a:r>
+          </a:p>
+        </p:txBody>
+      </p:sp>
+      <p:sp>
+        <p:nvSpPr>
+          <p:cNvPr id="106" name="r106"/>
+          <p:cNvSpPr/>
+          <p:nvPr/>
+        </p:nvSpPr>
+        <p:spPr>
+          <a:xfrm>
+            <a:off x="7366000" y="2159000"/>
+            <a:ext cx="4318000" cy="457200"/>
+          </a:xfrm>
+          <a:prstGeom prst="rect">
+            <a:avLst/>
+          </a:prstGeom>
+          <a:solidFill>
+            <a:srgbClr val="935739"/>
+          </a:solidFill>
+          <a:ln w="10160">
+            <a:solidFill>
+              <a:srgbClr val="935739"/>
+            </a:solidFill>
+          </a:ln>
+        </p:spPr>
+        <p:txBody>
+          <a:bodyPr wrap="square" lIns="76200" tIns="38100" rIns="76200" bIns="38100" anchor="ctr"/>
+          <a:lstStyle/>
+          <a:p>
+            <a:pPr algn="ctr"/>
+            <a:endParaRPr lang="en-US"/>
+          </a:p>
+        </p:txBody>
+      </p:sp>
+      <p:sp>
+        <p:nvSpPr>
+          <p:cNvPr id="107" name="t107"/>
+          <p:cNvSpPr txBox="1"/>
+          <p:nvPr/>
+        </p:nvSpPr>
+        <p:spPr>
+          <a:xfrm>
+            <a:off x="7467600" y="2159000"/>
+            <a:ext cx="4114800" cy="457200"/>
+          </a:xfrm>
+          <a:prstGeom prst="rect">
+            <a:avLst/>
+          </a:prstGeom>
+          <a:noFill/>
+          <a:ln>
+            <a:noFill/>
+          </a:ln>
+        </p:spPr>
+        <p:txBody>
+          <a:bodyPr wrap="square" lIns="76200" tIns="38100" rIns="76200" bIns="38100" anchor="ctr"/>
+          <a:lstStyle/>
+          <a:p>
+            <a:pPr algn="l">
+              <a:buNone/>
+            </a:pPr>
+            <a:r>
+              <a:rPr lang="en-US" sz="1500" b="1" dirty="0">
+                <a:solidFill>
+                  <a:srgbClr val="2A231F"/>
+                </a:solidFill>
+                <a:latin typeface="Arial"/>
+              </a:rPr>
+              <a:t>Evidence in thesis</a:t>
+            </a:r>
+          </a:p>
+        </p:txBody>
+      </p:sp>
+      <p:sp>
+        <p:nvSpPr>
+          <p:cNvPr id="108" name="r108"/>
+          <p:cNvSpPr/>
+          <p:nvPr/>
+        </p:nvSpPr>
+        <p:spPr>
+          <a:xfrm>
+            <a:off x="508000" y="2616200"/>
+            <a:ext cx="2540000" cy="711200"/>
+          </a:xfrm>
+          <a:prstGeom prst="rect">
+            <a:avLst/>
+          </a:prstGeom>
+          <a:solidFill>
+            <a:srgbClr val="FFFFFF"/>
+          </a:solidFill>
+          <a:ln w="10160">
+            <a:solidFill>
+              <a:srgbClr val="935739"/>
+            </a:solidFill>
+          </a:ln>
+        </p:spPr>
+        <p:txBody>
+          <a:bodyPr wrap="square" lIns="76200" tIns="38100" rIns="76200" bIns="38100" anchor="ctr"/>
+          <a:lstStyle/>
+          <a:p>
+            <a:endParaRPr lang="en-US"/>
+          </a:p>
+        </p:txBody>
+      </p:sp>
+      <p:sp>
+        <p:nvSpPr>
+          <p:cNvPr id="109" name="t109"/>
+          <p:cNvSpPr txBox="1"/>
+          <p:nvPr/>
+        </p:nvSpPr>
+        <p:spPr>
+          <a:xfrm>
+            <a:off x="609600" y="2616200"/>
+            <a:ext cx="2336800" cy="711200"/>
+          </a:xfrm>
+          <a:prstGeom prst="rect">
+            <a:avLst/>
+          </a:prstGeom>
+          <a:noFill/>
+          <a:ln>
+            <a:noFill/>
+          </a:ln>
+        </p:spPr>
+        <p:txBody>
+          <a:bodyPr wrap="square" lIns="76200" tIns="38100" rIns="76200" bIns="38100" anchor="ctr"/>
+          <a:lstStyle/>
+          <a:p>
+            <a:pPr algn="l">
+              <a:buNone/>
+            </a:pPr>
+            <a:r>
+              <a:rPr lang="en-US" sz="1400" dirty="0">
+                <a:solidFill>
+                  <a:srgbClr val="2A231F"/>
+                </a:solidFill>
+                <a:latin typeface="Arial"/>
+              </a:rPr>
+              <a:t>Signals &amp; Systems</a:t>
+            </a:r>
+          </a:p>
+        </p:txBody>
+      </p:sp>
+      <p:sp>
+        <p:nvSpPr>
+          <p:cNvPr id="110" name="r110"/>
+          <p:cNvSpPr/>
+          <p:nvPr/>
+        </p:nvSpPr>
+        <p:spPr>
+          <a:xfrm>
+            <a:off x="3048000" y="2616200"/>
+            <a:ext cx="4318000" cy="711200"/>
+          </a:xfrm>
+          <a:prstGeom prst="rect">
+            <a:avLst/>
+          </a:prstGeom>
+          <a:solidFill>
+            <a:srgbClr val="FFFFFF"/>
+          </a:solidFill>
+          <a:ln w="10160">
+            <a:solidFill>
+              <a:srgbClr val="935739"/>
+            </a:solidFill>
+          </a:ln>
+        </p:spPr>
+        <p:txBody>
+          <a:bodyPr wrap="square" lIns="76200" tIns="38100" rIns="76200" bIns="38100" anchor="ctr"/>
+          <a:lstStyle/>
+          <a:p>
+            <a:endParaRPr lang="en-US"/>
+          </a:p>
+        </p:txBody>
+      </p:sp>
+      <p:sp>
+        <p:nvSpPr>
+          <p:cNvPr id="111" name="t111"/>
+          <p:cNvSpPr txBox="1"/>
+          <p:nvPr/>
+        </p:nvSpPr>
+        <p:spPr>
+          <a:xfrm>
+            <a:off x="3149600" y="2616200"/>
+            <a:ext cx="4114800" cy="711200"/>
+          </a:xfrm>
+          <a:prstGeom prst="rect">
+            <a:avLst/>
+          </a:prstGeom>
+          <a:noFill/>
+          <a:ln>
+            <a:noFill/>
+          </a:ln>
+        </p:spPr>
+        <p:txBody>
+          <a:bodyPr wrap="square" lIns="76200" tIns="38100" rIns="76200" bIns="38100" anchor="ctr"/>
+          <a:lstStyle/>
+          <a:p>
+            <a:pPr algn="l">
+              <a:buNone/>
+            </a:pPr>
+            <a:r>
+              <a:rPr lang="en-US" sz="1400" dirty="0">
+                <a:solidFill>
+                  <a:srgbClr val="2A231F"/>
+                </a:solidFill>
+                <a:latin typeface="Arial"/>
+              </a:rPr>
+              <a:t>Kalman filter, EMA, frequency domain</a:t>
+            </a:r>
+          </a:p>
+        </p:txBody>
+      </p:sp>
+      <p:sp>
+        <p:nvSpPr>
+          <p:cNvPr id="112" name="r112"/>
+          <p:cNvSpPr/>
+          <p:nvPr/>
+        </p:nvSpPr>
+        <p:spPr>
+          <a:xfrm>
+            <a:off x="7366000" y="2616200"/>
+            <a:ext cx="4318000" cy="711200"/>
+          </a:xfrm>
+          <a:prstGeom prst="rect">
+            <a:avLst/>
+          </a:prstGeom>
+          <a:solidFill>
+            <a:srgbClr val="FFFFFF"/>
+          </a:solidFill>
+          <a:ln w="10160">
+            <a:solidFill>
+              <a:srgbClr val="935739"/>
+            </a:solidFill>
+          </a:ln>
+        </p:spPr>
+        <p:txBody>
+          <a:bodyPr wrap="square" lIns="76200" tIns="38100" rIns="76200" bIns="38100" anchor="ctr"/>
+          <a:lstStyle/>
+          <a:p>
+            <a:endParaRPr lang="en-US"/>
+          </a:p>
+        </p:txBody>
+      </p:sp>
+      <p:sp>
+        <p:nvSpPr>
+          <p:cNvPr id="113" name="t113"/>
+          <p:cNvSpPr txBox="1"/>
+          <p:nvPr/>
+        </p:nvSpPr>
+        <p:spPr>
+          <a:xfrm>
+            <a:off x="7467600" y="2616200"/>
+            <a:ext cx="4114800" cy="711200"/>
+          </a:xfrm>
+          <a:prstGeom prst="rect">
+            <a:avLst/>
+          </a:prstGeom>
+          <a:noFill/>
+          <a:ln>
+            <a:noFill/>
+          </a:ln>
+        </p:spPr>
+        <p:txBody>
+          <a:bodyPr wrap="square" lIns="76200" tIns="38100" rIns="76200" bIns="38100" anchor="ctr"/>
+          <a:lstStyle/>
+          <a:p>
+            <a:pPr algn="l">
+              <a:buNone/>
+            </a:pPr>
+            <a:r>
+              <a:rPr lang="en-US" sz="1400" dirty="0">
+                <a:solidFill>
+                  <a:srgbClr val="2A231F"/>
+                </a:solidFill>
+                <a:latin typeface="Arial"/>
+              </a:rPr>
+              <a:t>Per-joint CV Kalman; adaptive EMA tuning</a:t>
+            </a:r>
+          </a:p>
+        </p:txBody>
+      </p:sp>
+      <p:sp>
+        <p:nvSpPr>
+          <p:cNvPr id="114" name="r114"/>
+          <p:cNvSpPr/>
+          <p:nvPr/>
+        </p:nvSpPr>
+        <p:spPr>
+          <a:xfrm>
+            <a:off x="508000" y="3327400"/>
+            <a:ext cx="2540000" cy="711200"/>
+          </a:xfrm>
+          <a:prstGeom prst="rect">
+            <a:avLst/>
+          </a:prstGeom>
+          <a:solidFill>
+            <a:srgbClr val="FBF8F5"/>
+          </a:solidFill>
+          <a:ln w="10160">
+            <a:solidFill>
+              <a:srgbClr val="935739"/>
+            </a:solidFill>
+          </a:ln>
+        </p:spPr>
+        <p:txBody>
+          <a:bodyPr wrap="square" lIns="76200" tIns="38100" rIns="76200" bIns="38100" anchor="ctr"/>
+          <a:lstStyle/>
+          <a:p>
+            <a:endParaRPr lang="en-US"/>
+          </a:p>
+        </p:txBody>
+      </p:sp>
+      <p:sp>
+        <p:nvSpPr>
+          <p:cNvPr id="115" name="t115"/>
+          <p:cNvSpPr txBox="1"/>
+          <p:nvPr/>
+        </p:nvSpPr>
+        <p:spPr>
+          <a:xfrm>
+            <a:off x="609600" y="3327400"/>
+            <a:ext cx="2336800" cy="711200"/>
+          </a:xfrm>
+          <a:prstGeom prst="rect">
+            <a:avLst/>
+          </a:prstGeom>
+          <a:noFill/>
+          <a:ln>
+            <a:noFill/>
+          </a:ln>
+        </p:spPr>
+        <p:txBody>
+          <a:bodyPr wrap="square" lIns="76200" tIns="38100" rIns="76200" bIns="38100" anchor="ctr"/>
+          <a:lstStyle/>
+          <a:p>
+            <a:pPr algn="l">
+              <a:buNone/>
+            </a:pPr>
+            <a:r>
+              <a:rPr lang="en-US" sz="1400" dirty="0">
+                <a:solidFill>
+                  <a:srgbClr val="2A231F"/>
+                </a:solidFill>
+                <a:latin typeface="Arial"/>
+              </a:rPr>
+              <a:t>Control Systems</a:t>
+            </a:r>
+          </a:p>
+        </p:txBody>
+      </p:sp>
+      <p:sp>
+        <p:nvSpPr>
+          <p:cNvPr id="116" name="r116"/>
+          <p:cNvSpPr/>
+          <p:nvPr/>
+        </p:nvSpPr>
+        <p:spPr>
+          <a:xfrm>
+            <a:off x="3048000" y="3327400"/>
+            <a:ext cx="4318000" cy="711200"/>
+          </a:xfrm>
+          <a:prstGeom prst="rect">
+            <a:avLst/>
+          </a:prstGeom>
+          <a:solidFill>
+            <a:srgbClr val="FBF8F5"/>
+          </a:solidFill>
+          <a:ln w="10160">
+            <a:solidFill>
+              <a:srgbClr val="935739"/>
+            </a:solidFill>
+          </a:ln>
+        </p:spPr>
+        <p:txBody>
+          <a:bodyPr wrap="square" lIns="76200" tIns="38100" rIns="76200" bIns="38100" anchor="ctr"/>
+          <a:lstStyle/>
+          <a:p>
+            <a:endParaRPr lang="en-US"/>
+          </a:p>
+        </p:txBody>
+      </p:sp>
+      <p:sp>
+        <p:nvSpPr>
+          <p:cNvPr id="117" name="t117"/>
+          <p:cNvSpPr txBox="1"/>
+          <p:nvPr/>
+        </p:nvSpPr>
+        <p:spPr>
+          <a:xfrm>
+            <a:off x="3149600" y="3327400"/>
+            <a:ext cx="4114800" cy="711200"/>
+          </a:xfrm>
+          <a:prstGeom prst="rect">
+            <a:avLst/>
+          </a:prstGeom>
+          <a:noFill/>
+          <a:ln>
+            <a:noFill/>
+          </a:ln>
+        </p:spPr>
+        <p:txBody>
+          <a:bodyPr wrap="square" lIns="76200" tIns="38100" rIns="76200" bIns="38100" anchor="ctr"/>
+          <a:lstStyle/>
+          <a:p>
+            <a:pPr algn="l">
+              <a:buNone/>
+            </a:pPr>
+            <a:r>
+              <a:rPr lang="en-US" sz="1400" dirty="0">
+                <a:solidFill>
+                  <a:srgbClr val="2A231F"/>
+                </a:solidFill>
+                <a:latin typeface="Arial"/>
+              </a:rPr>
+              <a:t>Closed-loop feedback, stability</a:t>
+            </a:r>
+          </a:p>
+        </p:txBody>
+      </p:sp>
+      <p:sp>
+        <p:nvSpPr>
+          <p:cNvPr id="118" name="r118"/>
+          <p:cNvSpPr/>
+          <p:nvPr/>
+        </p:nvSpPr>
+        <p:spPr>
+          <a:xfrm>
+            <a:off x="7366000" y="3327400"/>
+            <a:ext cx="4318000" cy="711200"/>
+          </a:xfrm>
+          <a:prstGeom prst="rect">
+            <a:avLst/>
+          </a:prstGeom>
+          <a:solidFill>
+            <a:srgbClr val="FBF8F5"/>
+          </a:solidFill>
+          <a:ln w="10160">
+            <a:solidFill>
+              <a:srgbClr val="935739"/>
+            </a:solidFill>
+          </a:ln>
+        </p:spPr>
+        <p:txBody>
+          <a:bodyPr wrap="square" lIns="76200" tIns="38100" rIns="76200" bIns="38100" anchor="ctr"/>
+          <a:lstStyle/>
+          <a:p>
+            <a:endParaRPr lang="en-US"/>
+          </a:p>
+        </p:txBody>
+      </p:sp>
+      <p:sp>
+        <p:nvSpPr>
+          <p:cNvPr id="119" name="t119"/>
+          <p:cNvSpPr txBox="1"/>
+          <p:nvPr/>
+        </p:nvSpPr>
+        <p:spPr>
+          <a:xfrm>
+            <a:off x="7467600" y="3327400"/>
+            <a:ext cx="4114800" cy="711200"/>
+          </a:xfrm>
+          <a:prstGeom prst="rect">
+            <a:avLst/>
+          </a:prstGeom>
+          <a:noFill/>
+          <a:ln>
+            <a:noFill/>
+          </a:ln>
+        </p:spPr>
+        <p:txBody>
+          <a:bodyPr wrap="square" lIns="76200" tIns="38100" rIns="76200" bIns="38100" anchor="ctr"/>
+          <a:lstStyle/>
+          <a:p>
+            <a:pPr algn="l">
+              <a:buNone/>
+            </a:pPr>
+            <a:r>
+              <a:rPr lang="en-US" sz="1400" dirty="0">
+                <a:solidFill>
+                  <a:srgbClr val="2A231F"/>
+                </a:solidFill>
+                <a:latin typeface="Arial"/>
+              </a:rPr>
+              <a:t>Supervisor → FSM → motor loop; stop paths</a:t>
+            </a:r>
+          </a:p>
+        </p:txBody>
+      </p:sp>
+      <p:sp>
+        <p:nvSpPr>
+          <p:cNvPr id="120" name="r120"/>
+          <p:cNvSpPr/>
+          <p:nvPr/>
+        </p:nvSpPr>
+        <p:spPr>
+          <a:xfrm>
+            <a:off x="508000" y="4038600"/>
+            <a:ext cx="2540000" cy="711200"/>
+          </a:xfrm>
+          <a:prstGeom prst="rect">
+            <a:avLst/>
+          </a:prstGeom>
+          <a:solidFill>
+            <a:srgbClr val="FFFFFF"/>
+          </a:solidFill>
+          <a:ln w="10160">
+            <a:solidFill>
+              <a:srgbClr val="935739"/>
+            </a:solidFill>
+          </a:ln>
+        </p:spPr>
+        <p:txBody>
+          <a:bodyPr wrap="square" lIns="76200" tIns="38100" rIns="76200" bIns="38100" anchor="ctr"/>
+          <a:lstStyle/>
+          <a:p>
+            <a:endParaRPr lang="en-US"/>
+          </a:p>
+        </p:txBody>
+      </p:sp>
+      <p:sp>
+        <p:nvSpPr>
+          <p:cNvPr id="121" name="t121"/>
+          <p:cNvSpPr txBox="1"/>
+          <p:nvPr/>
+        </p:nvSpPr>
+        <p:spPr>
+          <a:xfrm>
+            <a:off x="609600" y="4038600"/>
+            <a:ext cx="2336800" cy="711200"/>
+          </a:xfrm>
+          <a:prstGeom prst="rect">
+            <a:avLst/>
+          </a:prstGeom>
+          <a:noFill/>
+          <a:ln>
+            <a:noFill/>
+          </a:ln>
+        </p:spPr>
+        <p:txBody>
+          <a:bodyPr wrap="square" lIns="76200" tIns="38100" rIns="76200" bIns="38100" anchor="ctr"/>
+          <a:lstStyle/>
+          <a:p>
+            <a:pPr algn="l">
+              <a:buNone/>
+            </a:pPr>
+            <a:r>
+              <a:rPr lang="en-US" sz="1400" dirty="0">
+                <a:solidFill>
+                  <a:srgbClr val="2A231F"/>
+                </a:solidFill>
+                <a:latin typeface="Arial"/>
+              </a:rPr>
+              <a:t>Embedded Systems</a:t>
+            </a:r>
+          </a:p>
+        </p:txBody>
+      </p:sp>
+      <p:sp>
+        <p:nvSpPr>
+          <p:cNvPr id="122" name="r122"/>
+          <p:cNvSpPr/>
+          <p:nvPr/>
+        </p:nvSpPr>
+        <p:spPr>
+          <a:xfrm>
+            <a:off x="3048000" y="4038600"/>
+            <a:ext cx="4318000" cy="711200"/>
+          </a:xfrm>
+          <a:prstGeom prst="rect">
+            <a:avLst/>
+          </a:prstGeom>
+          <a:solidFill>
+            <a:srgbClr val="FFFFFF"/>
+          </a:solidFill>
+          <a:ln w="10160">
+            <a:solidFill>
+              <a:srgbClr val="935739"/>
+            </a:solidFill>
+          </a:ln>
+        </p:spPr>
+        <p:txBody>
+          <a:bodyPr wrap="square" lIns="76200" tIns="38100" rIns="76200" bIns="38100" anchor="ctr"/>
+          <a:lstStyle/>
+          <a:p>
+            <a:endParaRPr lang="en-US"/>
+          </a:p>
+        </p:txBody>
+      </p:sp>
+      <p:sp>
+        <p:nvSpPr>
+          <p:cNvPr id="123" name="t123"/>
+          <p:cNvSpPr txBox="1"/>
+          <p:nvPr/>
+        </p:nvSpPr>
+        <p:spPr>
+          <a:xfrm>
+            <a:off x="3149600" y="4038600"/>
+            <a:ext cx="4114800" cy="711200"/>
+          </a:xfrm>
+          <a:prstGeom prst="rect">
+            <a:avLst/>
+          </a:prstGeom>
+          <a:noFill/>
+          <a:ln>
+            <a:noFill/>
+          </a:ln>
+        </p:spPr>
+        <p:txBody>
+          <a:bodyPr wrap="square" lIns="76200" tIns="38100" rIns="76200" bIns="38100" anchor="ctr"/>
+          <a:lstStyle/>
+          <a:p>
+            <a:pPr algn="l">
+              <a:buNone/>
+            </a:pPr>
+            <a:r>
+              <a:rPr lang="en-US" sz="1400" dirty="0">
+                <a:solidFill>
+                  <a:srgbClr val="2A231F"/>
+                </a:solidFill>
+                <a:latin typeface="Arial"/>
+              </a:rPr>
+              <a:t>RTOS-like cooperative FSM, UART</a:t>
+            </a:r>
+          </a:p>
+        </p:txBody>
+      </p:sp>
+      <p:sp>
+        <p:nvSpPr>
+          <p:cNvPr id="124" name="r124"/>
+          <p:cNvSpPr/>
+          <p:nvPr/>
+        </p:nvSpPr>
+        <p:spPr>
+          <a:xfrm>
+            <a:off x="7366000" y="4038600"/>
+            <a:ext cx="4318000" cy="711200"/>
+          </a:xfrm>
+          <a:prstGeom prst="rect">
+            <a:avLst/>
+          </a:prstGeom>
+          <a:solidFill>
+            <a:srgbClr val="FFFFFF"/>
+          </a:solidFill>
+          <a:ln w="10160">
+            <a:solidFill>
+              <a:srgbClr val="935739"/>
+            </a:solidFill>
+          </a:ln>
+        </p:spPr>
+        <p:txBody>
+          <a:bodyPr wrap="square" lIns="76200" tIns="38100" rIns="76200" bIns="38100" anchor="ctr"/>
+          <a:lstStyle/>
+          <a:p>
+            <a:endParaRPr lang="en-US"/>
+          </a:p>
+        </p:txBody>
+      </p:sp>
+      <p:sp>
+        <p:nvSpPr>
+          <p:cNvPr id="125" name="t125"/>
+          <p:cNvSpPr txBox="1"/>
+          <p:nvPr/>
+        </p:nvSpPr>
+        <p:spPr>
+          <a:xfrm>
+            <a:off x="7467600" y="4038600"/>
+            <a:ext cx="4114800" cy="711200"/>
+          </a:xfrm>
+          <a:prstGeom prst="rect">
+            <a:avLst/>
+          </a:prstGeom>
+          <a:noFill/>
+          <a:ln>
+            <a:noFill/>
+          </a:ln>
+        </p:spPr>
+        <p:txBody>
+          <a:bodyPr wrap="square" lIns="76200" tIns="38100" rIns="76200" bIns="38100" anchor="ctr"/>
+          <a:lstStyle/>
+          <a:p>
+            <a:pPr algn="l">
+              <a:buNone/>
+            </a:pPr>
+            <a:r>
+              <a:rPr lang="en-US" sz="1400" dirty="0">
+                <a:solidFill>
+                  <a:srgbClr val="2A231F"/>
+                </a:solidFill>
+                <a:latin typeface="Arial"/>
+              </a:rPr>
+              <a:t>control_12_full.ino at 921,600 baud</a:t>
+            </a:r>
+          </a:p>
+        </p:txBody>
+      </p:sp>
+      <p:sp>
+        <p:nvSpPr>
+          <p:cNvPr id="126" name="r126"/>
+          <p:cNvSpPr/>
+          <p:nvPr/>
+        </p:nvSpPr>
+        <p:spPr>
+          <a:xfrm>
+            <a:off x="508000" y="4749800"/>
+            <a:ext cx="2540000" cy="711200"/>
+          </a:xfrm>
+          <a:prstGeom prst="rect">
+            <a:avLst/>
+          </a:prstGeom>
+          <a:solidFill>
+            <a:srgbClr val="FBF8F5"/>
+          </a:solidFill>
+          <a:ln w="10160">
+            <a:solidFill>
+              <a:srgbClr val="935739"/>
+            </a:solidFill>
+          </a:ln>
+        </p:spPr>
+        <p:txBody>
+          <a:bodyPr wrap="square" lIns="76200" tIns="38100" rIns="76200" bIns="38100" anchor="ctr"/>
+          <a:lstStyle/>
+          <a:p>
+            <a:endParaRPr lang="en-US"/>
+          </a:p>
+        </p:txBody>
+      </p:sp>
+      <p:sp>
+        <p:nvSpPr>
+          <p:cNvPr id="127" name="t127"/>
+          <p:cNvSpPr txBox="1"/>
+          <p:nvPr/>
+        </p:nvSpPr>
+        <p:spPr>
+          <a:xfrm>
+            <a:off x="609600" y="4749800"/>
+            <a:ext cx="2336800" cy="711200"/>
+          </a:xfrm>
+          <a:prstGeom prst="rect">
+            <a:avLst/>
+          </a:prstGeom>
+          <a:noFill/>
+          <a:ln>
+            <a:noFill/>
+          </a:ln>
+        </p:spPr>
+        <p:txBody>
+          <a:bodyPr wrap="square" lIns="76200" tIns="38100" rIns="76200" bIns="38100" anchor="ctr"/>
+          <a:lstStyle/>
+          <a:p>
+            <a:pPr algn="l">
+              <a:buNone/>
+            </a:pPr>
+            <a:r>
+              <a:rPr lang="en-US" sz="1400" dirty="0">
+                <a:solidFill>
+                  <a:srgbClr val="2A231F"/>
+                </a:solidFill>
+                <a:latin typeface="Arial"/>
+              </a:rPr>
+              <a:t>Computer Networks</a:t>
+            </a:r>
+          </a:p>
+        </p:txBody>
+      </p:sp>
+      <p:sp>
+        <p:nvSpPr>
+          <p:cNvPr id="128" name="r128"/>
+          <p:cNvSpPr/>
+          <p:nvPr/>
+        </p:nvSpPr>
+        <p:spPr>
+          <a:xfrm>
+            <a:off x="3048000" y="4749800"/>
+            <a:ext cx="4318000" cy="711200"/>
+          </a:xfrm>
+          <a:prstGeom prst="rect">
+            <a:avLst/>
+          </a:prstGeom>
+          <a:solidFill>
+            <a:srgbClr val="FBF8F5"/>
+          </a:solidFill>
+          <a:ln w="10160">
+            <a:solidFill>
+              <a:srgbClr val="935739"/>
+            </a:solidFill>
+          </a:ln>
+        </p:spPr>
+        <p:txBody>
+          <a:bodyPr wrap="square" lIns="76200" tIns="38100" rIns="76200" bIns="38100" anchor="ctr"/>
+          <a:lstStyle/>
+          <a:p>
+            <a:endParaRPr lang="en-US"/>
+          </a:p>
+        </p:txBody>
+      </p:sp>
+      <p:sp>
+        <p:nvSpPr>
+          <p:cNvPr id="129" name="t129"/>
+          <p:cNvSpPr txBox="1"/>
+          <p:nvPr/>
+        </p:nvSpPr>
+        <p:spPr>
+          <a:xfrm>
+            <a:off x="3149600" y="4749800"/>
+            <a:ext cx="4114800" cy="711200"/>
+          </a:xfrm>
+          <a:prstGeom prst="rect">
+            <a:avLst/>
+          </a:prstGeom>
+          <a:noFill/>
+          <a:ln>
+            <a:noFill/>
+          </a:ln>
+        </p:spPr>
+        <p:txBody>
+          <a:bodyPr wrap="square" lIns="76200" tIns="38100" rIns="76200" bIns="38100" anchor="ctr"/>
+          <a:lstStyle/>
+          <a:p>
+            <a:pPr algn="l">
+              <a:buNone/>
+            </a:pPr>
+            <a:r>
+              <a:rPr lang="en-US" sz="1400" dirty="0">
+                <a:solidFill>
+                  <a:srgbClr val="2A231F"/>
+                </a:solidFill>
+                <a:latin typeface="Arial"/>
+              </a:rPr>
+              <a:t>UDP vs TCP, link-loss handling</a:t>
+            </a:r>
+          </a:p>
+        </p:txBody>
+      </p:sp>
+      <p:sp>
+        <p:nvSpPr>
+          <p:cNvPr id="130" name="r130"/>
+          <p:cNvSpPr/>
+          <p:nvPr/>
+        </p:nvSpPr>
+        <p:spPr>
+          <a:xfrm>
+            <a:off x="7366000" y="4749800"/>
+            <a:ext cx="4318000" cy="711200"/>
+          </a:xfrm>
+          <a:prstGeom prst="rect">
+            <a:avLst/>
+          </a:prstGeom>
+          <a:solidFill>
+            <a:srgbClr val="FBF8F5"/>
+          </a:solidFill>
+          <a:ln w="10160">
+            <a:solidFill>
+              <a:srgbClr val="935739"/>
+            </a:solidFill>
+          </a:ln>
+        </p:spPr>
+        <p:txBody>
+          <a:bodyPr wrap="square" lIns="76200" tIns="38100" rIns="76200" bIns="38100" anchor="ctr"/>
+          <a:lstStyle/>
+          <a:p>
+            <a:endParaRPr lang="en-US"/>
+          </a:p>
+        </p:txBody>
+      </p:sp>
+      <p:sp>
+        <p:nvSpPr>
+          <p:cNvPr id="131" name="t131"/>
+          <p:cNvSpPr txBox="1"/>
+          <p:nvPr/>
+        </p:nvSpPr>
+        <p:spPr>
+          <a:xfrm>
+            <a:off x="7467600" y="4749800"/>
+            <a:ext cx="4114800" cy="711200"/>
+          </a:xfrm>
+          <a:prstGeom prst="rect">
+            <a:avLst/>
+          </a:prstGeom>
+          <a:noFill/>
+          <a:ln>
+            <a:noFill/>
+          </a:ln>
+        </p:spPr>
+        <p:txBody>
+          <a:bodyPr wrap="square" lIns="76200" tIns="38100" rIns="76200" bIns="38100" anchor="ctr"/>
+          <a:lstStyle/>
+          <a:p>
+            <a:pPr algn="l">
+              <a:buNone/>
+            </a:pPr>
+            <a:r>
+              <a:rPr lang="en-US" sz="1400" dirty="0">
+                <a:solidFill>
+                  <a:srgbClr val="2A231F"/>
+                </a:solidFill>
+                <a:latin typeface="Arial"/>
+              </a:rPr>
+              <a:t>UDP target broadcast + watchdog timeout</a:t>
+            </a:r>
+          </a:p>
+        </p:txBody>
+      </p:sp>
+      <p:sp>
+        <p:nvSpPr>
+          <p:cNvPr id="132" name="r132"/>
+          <p:cNvSpPr/>
+          <p:nvPr/>
+        </p:nvSpPr>
+        <p:spPr>
+          <a:xfrm>
+            <a:off x="508000" y="5461000"/>
+            <a:ext cx="2540000" cy="711200"/>
+          </a:xfrm>
+          <a:prstGeom prst="rect">
+            <a:avLst/>
+          </a:prstGeom>
+          <a:solidFill>
+            <a:srgbClr val="FFFFFF"/>
+          </a:solidFill>
+          <a:ln w="10160">
+            <a:solidFill>
+              <a:srgbClr val="935739"/>
+            </a:solidFill>
+          </a:ln>
+        </p:spPr>
+        <p:txBody>
+          <a:bodyPr wrap="square" lIns="76200" tIns="38100" rIns="76200" bIns="38100" anchor="ctr"/>
+          <a:lstStyle/>
+          <a:p>
+            <a:endParaRPr lang="en-US"/>
+          </a:p>
+        </p:txBody>
+      </p:sp>
+      <p:sp>
+        <p:nvSpPr>
+          <p:cNvPr id="133" name="t133"/>
+          <p:cNvSpPr txBox="1"/>
+          <p:nvPr/>
+        </p:nvSpPr>
+        <p:spPr>
+          <a:xfrm>
+            <a:off x="609600" y="5461000"/>
+            <a:ext cx="2336800" cy="711200"/>
+          </a:xfrm>
+          <a:prstGeom prst="rect">
+            <a:avLst/>
+          </a:prstGeom>
+          <a:noFill/>
+          <a:ln>
+            <a:noFill/>
+          </a:ln>
+        </p:spPr>
+        <p:txBody>
+          <a:bodyPr wrap="square" lIns="76200" tIns="38100" rIns="76200" bIns="38100" anchor="ctr"/>
+          <a:lstStyle/>
+          <a:p>
+            <a:pPr algn="l">
+              <a:buNone/>
+            </a:pPr>
+            <a:r>
+              <a:rPr lang="en-US" sz="1400" dirty="0">
+                <a:solidFill>
+                  <a:srgbClr val="2A231F"/>
+                </a:solidFill>
+                <a:latin typeface="Arial"/>
+              </a:rPr>
+              <a:t>Engineering Ethics</a:t>
+            </a:r>
+          </a:p>
+        </p:txBody>
+      </p:sp>
+      <p:sp>
+        <p:nvSpPr>
+          <p:cNvPr id="134" name="r134"/>
+          <p:cNvSpPr/>
+          <p:nvPr/>
+        </p:nvSpPr>
+        <p:spPr>
+          <a:xfrm>
+            <a:off x="3048000" y="5461000"/>
+            <a:ext cx="4318000" cy="711200"/>
+          </a:xfrm>
+          <a:prstGeom prst="rect">
+            <a:avLst/>
+          </a:prstGeom>
+          <a:solidFill>
+            <a:srgbClr val="FFFFFF"/>
+          </a:solidFill>
+          <a:ln w="10160">
+            <a:solidFill>
+              <a:srgbClr val="935739"/>
+            </a:solidFill>
+          </a:ln>
+        </p:spPr>
+        <p:txBody>
+          <a:bodyPr wrap="square" lIns="76200" tIns="38100" rIns="76200" bIns="38100" anchor="ctr"/>
+          <a:lstStyle/>
+          <a:p>
+            <a:endParaRPr lang="en-US"/>
+          </a:p>
+        </p:txBody>
+      </p:sp>
+      <p:sp>
+        <p:nvSpPr>
+          <p:cNvPr id="135" name="t135"/>
+          <p:cNvSpPr txBox="1"/>
+          <p:nvPr/>
+        </p:nvSpPr>
+        <p:spPr>
+          <a:xfrm>
+            <a:off x="3149600" y="5461000"/>
+            <a:ext cx="4114800" cy="711200"/>
+          </a:xfrm>
+          <a:prstGeom prst="rect">
+            <a:avLst/>
+          </a:prstGeom>
+          <a:noFill/>
+          <a:ln>
+            <a:noFill/>
+          </a:ln>
+        </p:spPr>
+        <p:txBody>
+          <a:bodyPr wrap="square" lIns="76200" tIns="38100" rIns="76200" bIns="38100" anchor="ctr"/>
+          <a:lstStyle/>
+          <a:p>
+            <a:pPr algn="l">
+              <a:buNone/>
+            </a:pPr>
+            <a:r>
+              <a:rPr lang="en-US" sz="1400" dirty="0">
+                <a:solidFill>
+                  <a:srgbClr val="2A231F"/>
+                </a:solidFill>
+                <a:latin typeface="Arial"/>
+              </a:rPr>
+              <a:t>Risk, safety, responsible deployment</a:t>
+            </a:r>
+          </a:p>
+        </p:txBody>
+      </p:sp>
+      <p:sp>
+        <p:nvSpPr>
+          <p:cNvPr id="136" name="r136"/>
+          <p:cNvSpPr/>
+          <p:nvPr/>
+        </p:nvSpPr>
+        <p:spPr>
+          <a:xfrm>
+            <a:off x="7366000" y="5461000"/>
+            <a:ext cx="4318000" cy="711200"/>
+          </a:xfrm>
+          <a:prstGeom prst="rect">
+            <a:avLst/>
+          </a:prstGeom>
+          <a:solidFill>
+            <a:srgbClr val="FFFFFF"/>
+          </a:solidFill>
+          <a:ln w="10160">
+            <a:solidFill>
+              <a:srgbClr val="935739"/>
+            </a:solidFill>
+          </a:ln>
+        </p:spPr>
+        <p:txBody>
+          <a:bodyPr wrap="square" lIns="76200" tIns="38100" rIns="76200" bIns="38100" anchor="ctr"/>
+          <a:lstStyle/>
+          <a:p>
+            <a:endParaRPr lang="en-US"/>
+          </a:p>
+        </p:txBody>
+      </p:sp>
+      <p:sp>
+        <p:nvSpPr>
+          <p:cNvPr id="137" name="t137"/>
+          <p:cNvSpPr txBox="1"/>
+          <p:nvPr/>
+        </p:nvSpPr>
+        <p:spPr>
+          <a:xfrm>
+            <a:off x="7467600" y="5461000"/>
+            <a:ext cx="4114800" cy="711200"/>
+          </a:xfrm>
+          <a:prstGeom prst="rect">
+            <a:avLst/>
+          </a:prstGeom>
+          <a:noFill/>
+          <a:ln>
+            <a:noFill/>
+          </a:ln>
+        </p:spPr>
+        <p:txBody>
+          <a:bodyPr wrap="square" lIns="76200" tIns="38100" rIns="76200" bIns="38100" anchor="ctr"/>
+          <a:lstStyle/>
+          <a:p>
+            <a:pPr algn="l">
+              <a:buNone/>
+            </a:pPr>
+            <a:r>
+              <a:rPr lang="en-US" sz="1400" dirty="0">
+                <a:solidFill>
+                  <a:srgbClr val="2A231F"/>
+                </a:solidFill>
+                <a:latin typeface="Arial"/>
+              </a:rPr>
+              <a:t>ISO 12100 / 13849-1 / IEC 60204-1 alignment</a:t>
+            </a:r>
+          </a:p>
+        </p:txBody>
+      </p:sp>
+      <p:sp>
+        <p:nvSpPr>
+          <p:cNvPr id="138" name="r138"/>
+          <p:cNvSpPr/>
+          <p:nvPr/>
+        </p:nvSpPr>
+        <p:spPr>
+          <a:xfrm>
+            <a:off x="0" y="6350000"/>
+            <a:ext cx="12192000" cy="508000"/>
+          </a:xfrm>
+          <a:prstGeom prst="rect">
+            <a:avLst/>
+          </a:prstGeom>
+          <a:solidFill>
+            <a:srgbClr val="935739"/>
+          </a:solidFill>
+          <a:ln w="6350">
+            <a:solidFill>
+              <a:srgbClr val="935739"/>
+            </a:solidFill>
+          </a:ln>
+        </p:spPr>
+        <p:txBody>
+          <a:bodyPr wrap="square" anchor="ctr"/>
+          <a:lstStyle/>
+          <a:p>
+            <a:endParaRPr lang="en-US"/>
+          </a:p>
+        </p:txBody>
+      </p:sp>
+      <p:sp>
+        <p:nvSpPr>
+          <p:cNvPr id="139" name="t139"/>
+          <p:cNvSpPr txBox="1"/>
+          <p:nvPr/>
+        </p:nvSpPr>
+        <p:spPr>
+          <a:xfrm>
+            <a:off x="508000" y="6350000"/>
+            <a:ext cx="11176000" cy="508000"/>
+          </a:xfrm>
+          <a:prstGeom prst="rect">
+            <a:avLst/>
+          </a:prstGeom>
+          <a:noFill/>
+          <a:ln>
+            <a:noFill/>
+          </a:ln>
+        </p:spPr>
+        <p:txBody>
+          <a:bodyPr wrap="square" lIns="76200" tIns="38100" rIns="76200" bIns="38100" anchor="ctr"/>
+          <a:lstStyle/>
+          <a:p>
+            <a:pPr algn="l">
+              <a:buNone/>
+            </a:pPr>
+            <a:r>
+              <a:rPr lang="en-US" sz="1600" i="1" dirty="0">
+                <a:solidFill>
+                  <a:srgbClr val="2A231F"/>
+                </a:solidFill>
+                <a:latin typeface="Arial"/>
+              </a:rPr>
+              <a:t>Use only if asked which courses prepared you for this.</a:t>
+            </a:r>
+          </a:p>
+        </p:txBody>
+      </p:sp>
+      <p:sp>
+        <p:nvSpPr>
+          <p:cNvPr id="143" name="Rectangle 142"/>
+          <p:cNvSpPr/>
+          <p:nvPr/>
+        </p:nvSpPr>
+        <p:spPr>
+          <a:xfrm>
+            <a:off x="10363200" y="137160"/>
+            <a:ext cx="1645920" cy="320040"/>
+          </a:xfrm>
+          <a:prstGeom prst="rect">
+            <a:avLst/>
+          </a:prstGeom>
+          <a:noFill/>
+          <a:ln>
+            <a:noFill/>
+          </a:ln>
+        </p:spPr>
+        <p:style>
+          <a:lnRef idx="1">
+            <a:schemeClr val="accent1"/>
+          </a:lnRef>
+          <a:fillRef idx="3">
+            <a:schemeClr val="accent1"/>
+          </a:fillRef>
+          <a:effectRef idx="2">
+            <a:schemeClr val="accent1"/>
+          </a:effectRef>
+          <a:fontRef idx="minor">
+            <a:schemeClr val="lt1"/>
+          </a:fontRef>
+        </p:style>
+        <p:txBody>
+          <a:bodyPr wrap="none" rtlCol="0" anchor="ctr"/>
+          <a:lstStyle/>
+          <a:p>
+            <a:pPr algn="r">
+              <a:defRPr sz="1000" b="1">
+                <a:solidFill>
+                  <a:srgbClr val="8A8A8A"/>
+                </a:solidFill>
+                <a:latin typeface="Calibri"/>
+              </a:defRPr>
+            </a:pPr>
+            <a:r>
+              <a:t>SEDS · NU</a:t>
+            </a:r>
+          </a:p>
+        </p:txBody>
+      </p:sp>
+      <p:sp>
+        <p:nvSpPr>
+          <p:cNvPr id="144" name="Rectangle 143"/>
+          <p:cNvSpPr/>
+          <p:nvPr/>
+        </p:nvSpPr>
+        <p:spPr>
+          <a:xfrm>
+            <a:off x="10363200" y="457200"/>
+            <a:ext cx="1371600" cy="365760"/>
+          </a:xfrm>
+          <a:prstGeom prst="rect">
+            <a:avLst/>
+          </a:prstGeom>
+          <a:solidFill>
+            <a:srgbClr val="E88B40"/>
+          </a:solidFill>
+          <a:ln>
+            <a:noFill/>
+          </a:ln>
+        </p:spPr>
+        <p:style>
+          <a:lnRef idx="1">
+            <a:schemeClr val="accent1"/>
+          </a:lnRef>
+          <a:fillRef idx="3">
+            <a:schemeClr val="accent1"/>
+          </a:fillRef>
+          <a:effectRef idx="2">
+            <a:schemeClr val="accent1"/>
+          </a:effectRef>
+          <a:fontRef idx="minor">
+            <a:schemeClr val="lt1"/>
+          </a:fontRef>
+        </p:style>
+        <p:txBody>
+          <a:bodyPr rtlCol="0" anchor="ctr"/>
+          <a:lstStyle/>
+          <a:p>
+            <a:pPr algn="ctr">
+              <a:defRPr sz="1400" b="1">
+                <a:solidFill>
+                  <a:srgbClr val="FFFFFF"/>
+                </a:solidFill>
+                <a:latin typeface="Calibri"/>
+              </a:defRPr>
+            </a:pPr>
+            <a:r>
+              <a:t>APPENDIX</a:t>
+            </a:r>
+          </a:p>
+        </p:txBody>
+      </p:sp>
+      <p:sp>
+        <p:nvSpPr>
+          <p:cNvPr id="145" name="Rectangle 144"/>
+          <p:cNvSpPr/>
+          <p:nvPr/>
+        </p:nvSpPr>
+        <p:spPr>
+          <a:xfrm>
+            <a:off x="457200" y="6126480"/>
+            <a:ext cx="10972800" cy="274320"/>
+          </a:xfrm>
+          <a:prstGeom prst="rect">
+            <a:avLst/>
+          </a:prstGeom>
+          <a:noFill/>
+          <a:ln>
+            <a:noFill/>
+          </a:ln>
+        </p:spPr>
+        <p:style>
+          <a:lnRef idx="1">
+            <a:schemeClr val="accent1"/>
+          </a:lnRef>
+          <a:fillRef idx="3">
+            <a:schemeClr val="accent1"/>
+          </a:fillRef>
+          <a:effectRef idx="2">
+            <a:schemeClr val="accent1"/>
+          </a:effectRef>
+          <a:fontRef idx="minor">
+            <a:schemeClr val="lt1"/>
+          </a:fontRef>
+        </p:style>
+        <p:txBody>
+          <a:bodyPr rtlCol="0" anchor="ctr"/>
+          <a:lstStyle/>
+          <a:p>
+            <a:pPr algn="ctr">
+              <a:defRPr sz="1100" i="1">
+                <a:solidFill>
+                  <a:srgbClr val="8A8A8A"/>
+                </a:solidFill>
+                <a:latin typeface="Calibri"/>
+              </a:defRPr>
+            </a:pPr>
+            <a:r>
+              <a:t>[Hidden slide — unhide only if panel asks a relevant question]</a:t>
+            </a:r>
+          </a:p>
+        </p:txBody>
+      </p:sp>
+      <p:sp>
+        <p:nvSpPr>
+          <p:cNvPr id="3" name="r100">
+            <a:extLst>
+              <a:ext uri="{FF2B5EF4-FFF2-40B4-BE49-F238E27FC236}">
+                <a16:creationId xmlns:a16="http://schemas.microsoft.com/office/drawing/2014/main" id="{870A77FA-55AB-2C84-A9B7-85EE9BCEEE0F}"/>
+              </a:ext>
+            </a:extLst>
+          </p:cNvPr>
+          <p:cNvSpPr/>
+          <p:nvPr/>
+        </p:nvSpPr>
+        <p:spPr>
+          <a:xfrm>
+            <a:off x="508000" y="1480406"/>
+            <a:ext cx="4976496" cy="74444"/>
+          </a:xfrm>
+          <a:prstGeom prst="rect">
+            <a:avLst/>
+          </a:prstGeom>
+          <a:solidFill>
+            <a:srgbClr val="935739"/>
+          </a:solidFill>
+          <a:ln>
+            <a:noFill/>
+          </a:ln>
+        </p:spPr>
+        <p:txBody>
+          <a:bodyPr wrap="square" anchor="ctr"/>
+          <a:lstStyle/>
+          <a:p>
+            <a:endParaRPr lang="en-US"/>
+          </a:p>
+        </p:txBody>
+      </p:sp>
+    </p:spTree>
+  </p:cSld>
+  <p:clrMapOvr>
+    <a:masterClrMapping/>
+  </p:clrMapOvr>
+</p:sld>
+</file>
+
 <file path=ppt/slides/slide3.xml><?xml version="1.0" encoding="utf-8"?>
 <p:sld xmlns:a="http://schemas.openxmlformats.org/drawingml/2006/main" xmlns:r="http://schemas.openxmlformats.org/officeDocument/2006/relationships" xmlns:p="http://schemas.openxmlformats.org/presentationml/2006/main">
   <p:cSld>
@@ -36822,8 +38609,8 @@
           <a:lstStyle/>
           <a:p>
             <a:r>
-              <a:rPr dirty="0"/>
-              <a:t>Practical actuation paired with low-cost sensing for under USD 200.</a:t>
+              <a:rPr/>
+              <a:t>Practical actuation paired with low-cost sensing — perception ≈USD 120, total ≈USD 358.</a:t>
             </a:r>
           </a:p>
         </p:txBody>
@@ -36926,13 +38713,13 @@
               <a:buNone/>
             </a:pPr>
             <a:r>
-              <a:rPr lang="en-US" sz="1400" i="1" dirty="0">
+              <a:rPr sz="1400" i="1">
                 <a:solidFill>
                   <a:srgbClr val="935739"/>
                 </a:solidFill>
                 <a:latin typeface="Arial"/>
               </a:rPr>
-              <a:t>Arena setup: 4 USB cameras at corners, BLM at centre, AprilTag fiducials on walls. All hardware fits in a domestic garage — no lab infrastructure required.</a:t>
+              <a:t>Arena setup: 4 USB cameras at corners, BLM at centre, 24 AprilTag fiducials on walls for extrinsic calibration (Sec 3.5). All hardware fits in a domestic garage — no lab infrastructure required.</a:t>
             </a:r>
           </a:p>
         </p:txBody>
@@ -37638,13 +39425,13 @@
               <a:buNone/>
             </a:pPr>
             <a:r>
-              <a:rPr lang="en-US" sz="1200" dirty="0">
+              <a:rPr sz="1200">
                 <a:solidFill>
                   <a:srgbClr val="2A231F"/>
                 </a:solidFill>
                 <a:latin typeface="Arial"/>
               </a:rPr>
-              <a:t>Perception PC (recycled)</a:t>
+              <a:t>Total</a:t>
             </a:r>
           </a:p>
         </p:txBody>
@@ -37676,13 +39463,13 @@
               <a:buNone/>
             </a:pPr>
             <a:r>
-              <a:rPr lang="en-US" sz="1200" dirty="0">
+              <a:rPr sz="1200">
                 <a:solidFill>
                   <a:srgbClr val="2A231F"/>
                 </a:solidFill>
                 <a:latin typeface="Arial"/>
               </a:rPr>
-              <a:t>-</a:t>
+              <a:t>≈USD 358</a:t>
             </a:r>
           </a:p>
         </p:txBody>
@@ -37745,31 +39532,13 @@
               <a:buNone/>
             </a:pPr>
             <a:r>
-              <a:rPr lang="en-US" sz="1600" b="0" i="1" dirty="0">
+              <a:rPr sz="1600" b="0" i="1">
                 <a:solidFill>
                   <a:srgbClr val="FFFFFF"/>
                 </a:solidFill>
                 <a:latin typeface="Arial"/>
               </a:rPr>
-              <a:t>Takeaway: expensive </a:t>
-            </a:r>
-            <a:r>
-              <a:rPr lang="en-US" sz="1600" b="0" i="1" dirty="0" err="1">
-                <a:solidFill>
-                  <a:srgbClr val="FFFFFF"/>
-                </a:solidFill>
-                <a:latin typeface="Arial"/>
-              </a:rPr>
-              <a:t>MoCap</a:t>
-            </a:r>
-            <a:r>
-              <a:rPr lang="en-US" sz="1600" b="0" i="1" dirty="0">
-                <a:solidFill>
-                  <a:srgbClr val="FFFFFF"/>
-                </a:solidFill>
-                <a:latin typeface="Arial"/>
-              </a:rPr>
-              <a:t> is not required for the validated pose-guided aiming pipeline.</a:t>
+              <a:t>Takeaway: expensive MoCap is not required for pose-guided aiming; perception is ≈USD 120, with ≈USD 358 for the full BLM (Sec 3.2, Table 3.2).</a:t>
             </a:r>
           </a:p>
         </p:txBody>
@@ -39140,13 +40909,13 @@
               <a:buNone/>
             </a:pPr>
             <a:r>
-              <a:rPr lang="en-US" sz="1400" dirty="0">
+              <a:rPr sz="1400">
                 <a:solidFill>
                   <a:srgbClr val="2A231F"/>
                 </a:solidFill>
                 <a:latin typeface="Arial"/>
               </a:rPr>
-              <a:t>iterative reprojection-error rejection</a:t>
+              <a:t>iterative reprojection-error rejection (Sec 3.7.2)</a:t>
             </a:r>
           </a:p>
         </p:txBody>
@@ -39275,11 +41044,10 @@
           <a:lstStyle/>
           <a:p>
             <a:r>
-              <a:rPr lang="en-US" sz="1400" dirty="0">
-                <a:latin typeface="Arial" panose="020B0604020202020204" pitchFamily="34" charset="0"/>
-                <a:cs typeface="Arial" panose="020B0604020202020204" pitchFamily="34" charset="0"/>
+              <a:rPr sz="1400">
+                <a:latin typeface="Arial"/>
               </a:rPr>
-              <a:t>adaptive EMA + CV Kalman prediction</a:t>
+              <a:t>adaptive EMA + CV Kalman (Sec 5.7)</a:t>
             </a:r>
             <a:endParaRPr sz="1400" dirty="0">
               <a:latin typeface="Arial" panose="020B0604020202020204" pitchFamily="34" charset="0"/>
@@ -39620,15 +41388,6 @@
             <a:pPr algn="l">
               <a:buNone/>
             </a:pPr>
-            <a:r>
-              <a:rPr lang="en-US" sz="1400" b="1" dirty="0">
-                <a:solidFill>
-                  <a:srgbClr val="2A231F"/>
-                </a:solidFill>
-                <a:latin typeface="Arial"/>
-              </a:rPr>
-              <a:t>  Firmware command excerpt</a:t>
-            </a:r>
           </a:p>
         </p:txBody>
       </p:sp>
@@ -39658,183 +41417,6 @@
             <a:pPr algn="l">
               <a:buNone/>
             </a:pPr>
-            <a:r>
-              <a:rPr lang="en-US" sz="1200" dirty="0">
-                <a:solidFill>
-                  <a:srgbClr val="2A231F"/>
-                </a:solidFill>
-                <a:latin typeface="Consolas"/>
-              </a:rPr>
-              <a:t>// control_12_full.ino</a:t>
-            </a:r>
-          </a:p>
-          <a:p>
-            <a:pPr algn="l">
-              <a:buNone/>
-            </a:pPr>
-            <a:r>
-              <a:rPr lang="en-US" sz="1200" dirty="0">
-                <a:solidFill>
-                  <a:srgbClr val="2A231F"/>
-                </a:solidFill>
-                <a:latin typeface="Consolas"/>
-              </a:rPr>
-              <a:t>void handle_set(){</a:t>
-            </a:r>
-          </a:p>
-          <a:p>
-            <a:pPr algn="l">
-              <a:buNone/>
-            </a:pPr>
-            <a:r>
-              <a:rPr lang="en-US" sz="1200" dirty="0">
-                <a:solidFill>
-                  <a:srgbClr val="2A231F"/>
-                </a:solidFill>
-                <a:latin typeface="Consolas"/>
-              </a:rPr>
-              <a:t>  // set &lt;v&gt; &lt;h&gt; &lt;wl&gt; &lt;wr&gt;</a:t>
-            </a:r>
-          </a:p>
-          <a:p>
-            <a:pPr algn="l">
-              <a:buNone/>
-            </a:pPr>
-            <a:r>
-              <a:rPr lang="en-US" sz="1200" dirty="0">
-                <a:solidFill>
-                  <a:srgbClr val="2A231F"/>
-                </a:solidFill>
-                <a:latin typeface="Consolas"/>
-              </a:rPr>
-              <a:t>  float v = Serial.parseFloat();</a:t>
-            </a:r>
-          </a:p>
-          <a:p>
-            <a:pPr algn="l">
-              <a:buNone/>
-            </a:pPr>
-            <a:r>
-              <a:rPr lang="en-US" sz="1200" dirty="0">
-                <a:solidFill>
-                  <a:srgbClr val="2A231F"/>
-                </a:solidFill>
-                <a:latin typeface="Consolas"/>
-              </a:rPr>
-              <a:t>  float h = Serial.parseFloat();</a:t>
-            </a:r>
-          </a:p>
-          <a:p>
-            <a:pPr algn="l">
-              <a:buNone/>
-            </a:pPr>
-            <a:r>
-              <a:rPr lang="en-US" sz="1200" dirty="0">
-                <a:solidFill>
-                  <a:srgbClr val="2A231F"/>
-                </a:solidFill>
-                <a:latin typeface="Consolas"/>
-              </a:rPr>
-              <a:t>  int wl = Serial.parseInt();</a:t>
-            </a:r>
-          </a:p>
-          <a:p>
-            <a:pPr algn="l">
-              <a:buNone/>
-            </a:pPr>
-            <a:r>
-              <a:rPr lang="en-US" sz="1200" dirty="0">
-                <a:solidFill>
-                  <a:srgbClr val="2A231F"/>
-                </a:solidFill>
-                <a:latin typeface="Consolas"/>
-              </a:rPr>
-              <a:t>  int wr = Serial.parseInt();</a:t>
-            </a:r>
-          </a:p>
-          <a:p>
-            <a:pPr algn="l">
-              <a:buNone/>
-            </a:pPr>
-            <a:r>
-              <a:rPr lang="en-US" sz="1200" dirty="0">
-                <a:solidFill>
-                  <a:srgbClr val="2A231F"/>
-                </a:solidFill>
-                <a:latin typeface="Consolas"/>
-              </a:rPr>
-              <a:t>  if(!armed) return;</a:t>
-            </a:r>
-          </a:p>
-          <a:p>
-            <a:pPr algn="l">
-              <a:buNone/>
-            </a:pPr>
-            <a:r>
-              <a:rPr lang="en-US" sz="1200" dirty="0">
-                <a:solidFill>
-                  <a:srgbClr val="2A231F"/>
-                </a:solidFill>
-                <a:latin typeface="Consolas"/>
-              </a:rPr>
-              <a:t>  clampAngle(v, h);</a:t>
-            </a:r>
-          </a:p>
-          <a:p>
-            <a:pPr algn="l">
-              <a:buNone/>
-            </a:pPr>
-            <a:r>
-              <a:rPr lang="en-US" sz="1200" dirty="0">
-                <a:solidFill>
-                  <a:srgbClr val="2A231F"/>
-                </a:solidFill>
-                <a:latin typeface="Consolas"/>
-              </a:rPr>
-              <a:t>  gateRPM(wl, wr);</a:t>
-            </a:r>
-          </a:p>
-          <a:p>
-            <a:pPr algn="l">
-              <a:buNone/>
-            </a:pPr>
-            <a:r>
-              <a:rPr lang="en-US" sz="1200" dirty="0">
-                <a:solidFill>
-                  <a:srgbClr val="2A231F"/>
-                </a:solidFill>
-                <a:latin typeface="Consolas"/>
-              </a:rPr>
-              <a:t>  target_v = v; target_h = h;</a:t>
-            </a:r>
-          </a:p>
-          <a:p>
-            <a:pPr algn="l">
-              <a:buNone/>
-            </a:pPr>
-            <a:r>
-              <a:rPr lang="en-US" sz="1200" dirty="0">
-                <a:solidFill>
-                  <a:srgbClr val="2A231F"/>
-                </a:solidFill>
-                <a:latin typeface="Consolas"/>
-              </a:rPr>
-              <a:t>  rpm_l = wl; rpm_r = wr;</a:t>
-            </a:r>
-          </a:p>
-          <a:p>
-            <a:pPr algn="l">
-              <a:buNone/>
-            </a:pPr>
-            <a:r>
-              <a:rPr lang="en-US" sz="1200" dirty="0">
-                <a:solidFill>
-                  <a:srgbClr val="2A231F"/>
-                </a:solidFill>
-                <a:latin typeface="Consolas"/>
-              </a:rPr>
-              <a:t>}</a:t>
-            </a:r>
           </a:p>
         </p:txBody>
       </p:sp>

</xml_diff>

<commit_message>
Defense deck: S12 P95 + S13 limitations 6 + S14 disadvantages + S15 dual-use
Batch C (Tasks 8-10 from plan). S12 carries raw 150.77 -> corrected 95.17
callout, all P95 numbers, per-joint P95. S13 expands to 6 numbered
limitations matching thesis Sec 6.3. S14 cost USD 358, adds Disadvantages
line (handbook criterion 7). S15 adds Dual-use sentence (Sec 6.5) and
implementation detail to each ISO standard row (NC E-STOP = Cat-1 stop,
24V/50A fuse, exclusion zone).

Co-Authored-By: Claude Opus 4.7 <noreply@anthropic.com>
</commit_message>
<xml_diff>
--- a/thesis_defense_presentation/thesis_defense_final_revised.pptx
+++ b/thesis_defense_presentation/thesis_defense_final_revised.pptx
@@ -21557,8 +21557,8 @@
           <a:lstStyle/>
           <a:p>
             <a:r>
-              <a:rPr lang="en-US" b="1" dirty="0"/>
-              <a:t>Acceptance thresholds met within the validated static/live-aim scope.</a:t>
+              <a:rPr b="1"/>
+              <a:t>All thresholds met within validated static/live-aim scope. Raw ball mean 150.77 mm → corrected 95.17 mm via in-sample bias model (Fig 5.1).</a:t>
             </a:r>
             <a:endParaRPr lang="en-US" dirty="0"/>
           </a:p>
@@ -21647,12 +21647,8 @@
           <a:lstStyle/>
           <a:p>
             <a:r>
-              <a:rPr dirty="0"/>
-              <a:t>corrected ball mean</a:t>
-            </a:r>
-            <a:r>
-              <a:rPr lang="en-US" dirty="0"/>
-              <a:t> error</a:t>
+              <a:rPr/>
+              <a:t>corrected ball mean (P95 166.51 mm)</a:t>
             </a:r>
             <a:endParaRPr dirty="0"/>
           </a:p>
@@ -21711,16 +21707,8 @@
           <a:lstStyle/>
           <a:p>
             <a:r>
-              <a:rPr dirty="0"/>
-              <a:t>joint mean</a:t>
-            </a:r>
-            <a:r>
-              <a:rPr lang="en-US" dirty="0"/>
-              <a:t> error</a:t>
-            </a:r>
-            <a:r>
-              <a:rPr dirty="0"/>
-              <a:t> (62 valid trials)</a:t>
+              <a:rPr/>
+              <a:t>joint mean over 62 valid trials (P95 198.73 mm)</a:t>
             </a:r>
           </a:p>
         </p:txBody>
@@ -21779,8 +21767,8 @@
           <a:lstStyle/>
           <a:p>
             <a:r>
-              <a:rPr dirty="0"/>
-              <a:t>knee / hip / shoulder means</a:t>
+              <a:rPr/>
+              <a:t>knee / hip / shoulder means; P95 171 / 172 / 200 mm (Table 5.3)</a:t>
             </a:r>
           </a:p>
         </p:txBody>
@@ -21838,8 +21826,8 @@
           <a:lstStyle/>
           <a:p>
             <a:r>
-              <a:rPr dirty="0"/>
-              <a:t>E-STOP latch response</a:t>
+              <a:rPr/>
+              <a:t>E-STOP latch response (Sec 3.14.3)</a:t>
             </a:r>
           </a:p>
         </p:txBody>
@@ -21897,7 +21885,8 @@
           <a:lstStyle/>
           <a:p>
             <a:r>
-              <a:t>live YOLO-Pose pipeline</a:t>
+              <a:rPr/>
+              <a:t>live YOLO-Pose pipeline; ≈15 ms compute, 52 ms headroom (Sec 3.3)</a:t>
             </a:r>
           </a:p>
         </p:txBody>
@@ -22558,24 +22547,39 @@
           <a:lstStyle/>
           <a:p>
             <a:r>
-              <a:rPr lang="en-US" b="1" dirty="0"/>
-              <a:t>Validated:</a:t>
-            </a:r>
-            <a:r>
-              <a:rPr lang="en-US" dirty="0"/>
-              <a:t> perception, 3D targeting, safety gates, and static/live-aim tests.</a:t>
-            </a:r>
-          </a:p>
-          <a:p>
-            <a:r>
-              <a:rPr lang="en-US" b="1" dirty="0"/>
-              <a:t>Pending</a:t>
-            </a:r>
-            <a:r>
-              <a:rPr lang="en-US" dirty="0"/>
-              <a:t>: moving-subject closed-loop firing.</a:t>
-            </a:r>
-            <a:endParaRPr dirty="0"/>
+              <a:rPr b="1"/>
+              <a:t>1. UNVALIDATED: closed-loop firing at a moving subject (Sec 1.3, 6.3)</a:t>
+            </a:r>
+          </a:p>
+          <a:p>
+            <a:r>
+              <a:rPr b="1"/>
+              <a:t>2. In-sample bias correction — fitted on same 36-pt set (Sec 4.4.2, 6.3)</a:t>
+            </a:r>
+          </a:p>
+          <a:p>
+            <a:r>
+              <a:rPr b="1"/>
+              <a:t>3. 19 / 81 joint-touch trials invalid (23.5 %) due to occlusion (Sec 5.4)</a:t>
+            </a:r>
+          </a:p>
+          <a:p>
+            <a:r>
+              <a:rPr b="1"/>
+              <a:t>4. RPM → velocity not empirically calibrated (Sec 5.9, 6.4.3)</a:t>
+            </a:r>
+          </a:p>
+          <a:p>
+            <a:r>
+              <a:rPr b="1"/>
+              <a:t>5. Single-person, single-arena, indoor-only evaluation (Sec 6.3)</a:t>
+            </a:r>
+          </a:p>
+          <a:p>
+            <a:r>
+              <a:rPr b="1"/>
+              <a:t>6. CV Kalman neutral on jump motion — IMM filter is future work (Sec 5.7)</a:t>
+            </a:r>
           </a:p>
         </p:txBody>
       </p:sp>
@@ -22634,12 +22638,8 @@
           <a:lstStyle/>
           <a:p>
             <a:r>
-              <a:rPr dirty="0">
-                <a:solidFill>
-                  <a:schemeClr val="bg1"/>
-                </a:solidFill>
-              </a:rPr>
-              <a:t>Takeaway: the validated scope (perception → safety-gated static shots) is a strong partial validation. The unvalidated boundary is precisely defined: moving-subject closed-loop firing.</a:t>
+              <a:rPr/>
+              <a:t>Takeaway: validated scope (perception → safety-gated single-shot live-aim) is a strong partial validation. The unvalidated boundary — moving-subject closed-loop firing — is precisely defined and is the next milestone.</a:t>
             </a:r>
           </a:p>
         </p:txBody>
@@ -23473,13 +23473,13 @@
               <a:buNone/>
             </a:pPr>
             <a:r>
-              <a:rPr lang="en-US" sz="1600" b="0" i="1" dirty="0">
+              <a:rPr sz="1600" b="0" i="1">
                 <a:solidFill>
                   <a:srgbClr val="FFFFFF"/>
                 </a:solidFill>
                 <a:latin typeface="Arial"/>
               </a:rPr>
-              <a:t>Takeaway: strong partial validation of a low-cost, pose-guided BLM system.</a:t>
+              <a:t>Takeaway: strong partial validation of a low-cost, pose-guided BLM. Disadvantages: in-sample bias fit · 3-camera occlusion floor · RPM → velocity not yet calibrated.</a:t>
             </a:r>
           </a:p>
         </p:txBody>
@@ -23651,8 +23651,8 @@
           <a:p>
             <a:pPr algn="ctr"/>
             <a:r>
-              <a:rPr lang="en-US" dirty="0"/>
-              <a:t>BLM aims from live 3D joints</a:t>
+              <a:rPr/>
+              <a:t>BLM aims live from 3D joints (Sec 5.9)</a:t>
             </a:r>
             <a:endParaRPr lang="ru-RU" dirty="0"/>
           </a:p>
@@ -23688,8 +23688,8 @@
           <a:p>
             <a:pPr algn="ctr"/>
             <a:r>
-              <a:rPr lang="es-ES" dirty="0"/>
-              <a:t>4 USB cameras, ≈USD 200</a:t>
+              <a:rPr/>
+              <a:t>4 USB cameras, ≈USD 120 perception / ≈USD 358 total</a:t>
             </a:r>
             <a:endParaRPr lang="ru-RU" dirty="0"/>
           </a:p>
@@ -23724,8 +23724,8 @@
           <a:lstStyle/>
           <a:p>
             <a:r>
-              <a:rPr lang="en-US" b="1" dirty="0"/>
-              <a:t>Safety-gated integration</a:t>
+              <a:rPr b="1"/>
+              <a:t>Safety-gated S0–S4 integration, E-STOP &lt;100 ms (Sec 3.14.3)</a:t>
             </a:r>
             <a:endParaRPr lang="ru-RU" b="1" dirty="0"/>
           </a:p>
@@ -23761,8 +23761,8 @@
           <a:p>
             <a:pPr algn="ctr"/>
             <a:r>
-              <a:rPr lang="en-US" dirty="0"/>
-              <a:t>Voice commands behind safety gates</a:t>
+              <a:rPr/>
+              <a:t>Voice + keyboard control behind safety gates (Sec 3.12)</a:t>
             </a:r>
             <a:endParaRPr lang="ru-RU" dirty="0"/>
           </a:p>
@@ -24112,13 +24112,13 @@
               <a:buNone/>
             </a:pPr>
             <a:r>
-              <a:rPr lang="en-US" sz="1400" dirty="0">
+              <a:rPr sz="1400">
                 <a:solidFill>
                   <a:srgbClr val="2A231F"/>
                 </a:solidFill>
                 <a:latin typeface="Arial"/>
               </a:rPr>
-              <a:t>Machinery safety — risk assessment</a:t>
+              <a:t>Machinery safety — L1–L10 hazard map (Sec 3.14)</a:t>
             </a:r>
           </a:p>
         </p:txBody>
@@ -24216,13 +24216,13 @@
               <a:buNone/>
             </a:pPr>
             <a:r>
-              <a:rPr lang="en-US" sz="1400" dirty="0">
+              <a:rPr sz="1400">
                 <a:solidFill>
                   <a:srgbClr val="2A231F"/>
                 </a:solidFill>
                 <a:latin typeface="Arial"/>
               </a:rPr>
-              <a:t>Safety-related control</a:t>
+              <a:t>Safety-related control — NC E-STOP = ISO 13849-1 Cat-1 stop (L8)</a:t>
             </a:r>
           </a:p>
         </p:txBody>
@@ -24320,13 +24320,13 @@
               <a:buNone/>
             </a:pPr>
             <a:r>
-              <a:rPr lang="en-US" sz="1400" dirty="0">
+              <a:rPr sz="1400">
                 <a:solidFill>
                   <a:srgbClr val="2A231F"/>
                 </a:solidFill>
                 <a:latin typeface="Arial"/>
               </a:rPr>
-              <a:t>Wiring, fusing, E-STOP</a:t>
+              <a:t>Wiring, fusing, E-STOP — 24V/50A fuse, single star-point ground (Sec 3.2)</a:t>
             </a:r>
           </a:p>
         </p:txBody>
@@ -24424,13 +24424,13 @@
               <a:buNone/>
             </a:pPr>
             <a:r>
-              <a:rPr lang="en-US" sz="1400" dirty="0">
+              <a:rPr sz="1400">
                 <a:solidFill>
                   <a:srgbClr val="2A231F"/>
                 </a:solidFill>
                 <a:latin typeface="Arial"/>
               </a:rPr>
-              <a:t>Human exclusion during operation</a:t>
+              <a:t>Operator-only zone during controlled fire (Sec 3.14.2)</a:t>
             </a:r>
           </a:p>
         </p:txBody>
@@ -24527,13 +24527,13 @@
               <a:buNone/>
             </a:pPr>
             <a:r>
-              <a:rPr lang="en-US" sz="1600" b="0" i="1" dirty="0">
+              <a:rPr sz="1600" b="0" i="1">
                 <a:solidFill>
                   <a:srgbClr val="FFFFFF"/>
                 </a:solidFill>
                 <a:latin typeface="Arial"/>
               </a:rPr>
-              <a:t>Takeaway: future work closes the moving-target loop while preserving safety, traceability, and ethical deployment.</a:t>
+              <a:t>Dual-use: a system capable of autonomously tracking human body parts and directing a projectile has obvious dual-use potential beyond sports training. Operator presence, hardware NC E-STOP, exclusion zone, and the six-stage protocol are the necessary safeguards (Sec 6.5).</a:t>
             </a:r>
           </a:p>
         </p:txBody>

</xml_diff>